<commit_message>
fix: changes to second half of slides after run-through
</commit_message>
<xml_diff>
--- a/slides/flsg/6-sampling-flsg.pptx
+++ b/slides/flsg/6-sampling-flsg.pptx
@@ -1527,58 +1527,7 @@
           <a:bodyPr/>
           <a:lstStyle/>
           <a:p>
-            <a:r>
-              <a:rPr lang="en-US" dirty="0"/>
-              <a:t>[TIMINGS]</a:t>
-            </a:r>
-          </a:p>
-          <a:p>
             <a:endParaRPr lang="en-US" dirty="0"/>
-          </a:p>
-          <a:p>
-            <a:r>
-              <a:rPr lang="en-US" dirty="0"/>
-              <a:t>Practice: 40m</a:t>
-            </a:r>
-          </a:p>
-          <a:p>
-            <a:r>
-              <a:rPr lang="en-US" dirty="0"/>
-              <a:t>Target: 45m</a:t>
-            </a:r>
-          </a:p>
-          <a:p>
-            <a:endParaRPr lang="en-US" dirty="0"/>
-          </a:p>
-          <a:p>
-            <a:r>
-              <a:rPr lang="en-US" dirty="0"/>
-              <a:t>Start time: 14:45</a:t>
-            </a:r>
-          </a:p>
-          <a:p>
-            <a:r>
-              <a:rPr lang="en-US" dirty="0"/>
-              <a:t>End time: 15:00</a:t>
-            </a:r>
-          </a:p>
-          <a:p>
-            <a:r>
-              <a:rPr lang="en-US" dirty="0"/>
-              <a:t>(BREAK UNTIL 15:30)</a:t>
-            </a:r>
-          </a:p>
-          <a:p>
-            <a:r>
-              <a:rPr lang="en-US" dirty="0"/>
-              <a:t>Finish time: 16:00</a:t>
-            </a:r>
-          </a:p>
-          <a:p>
-            <a:r>
-              <a:rPr lang="en-US" dirty="0"/>
-              <a:t>---</a:t>
-            </a:r>
           </a:p>
         </p:txBody>
       </p:sp>
@@ -6973,11 +6922,6 @@
               </a:rPr>
               <a:t>The Final Operation</a:t>
             </a:r>
-            <a:endParaRPr lang="en-GB" dirty="0">
-              <a:latin typeface="CMU Serif Roman" panose="02000603000000000000" pitchFamily="2" charset="0"/>
-              <a:ea typeface="CMU Serif Roman" panose="02000603000000000000" pitchFamily="2" charset="0"/>
-              <a:cs typeface="CMU Serif Roman" panose="02000603000000000000" pitchFamily="2" charset="0"/>
-            </a:endParaRPr>
           </a:p>
         </p:txBody>
       </p:sp>
@@ -16676,23 +16620,7 @@
                 <a:ea typeface="CMU Serif Roman" panose="02000603000000000000" pitchFamily="2" charset="0"/>
                 <a:cs typeface="CMU Serif Roman" panose="02000603000000000000" pitchFamily="2" charset="0"/>
               </a:rPr>
-              <a:t>From </a:t>
-            </a:r>
-            <a:r>
-              <a:rPr lang="en-GB" dirty="0">
-                <a:latin typeface="CMU Serif Roman" panose="02000603000000000000" pitchFamily="2" charset="0"/>
-                <a:ea typeface="CMU Serif Roman" panose="02000603000000000000" pitchFamily="2" charset="0"/>
-                <a:cs typeface="CMU Serif Roman" panose="02000603000000000000" pitchFamily="2" charset="0"/>
-              </a:rPr>
-              <a:t>the Last S</a:t>
-            </a:r>
-            <a:r>
-              <a:rPr lang="en-GB" dirty="0">
-                <a:latin typeface="CMU Serif Roman" panose="02000603000000000000" pitchFamily="2" charset="0"/>
-                <a:ea typeface="CMU Serif Roman" panose="02000603000000000000" pitchFamily="2" charset="0"/>
-                <a:cs typeface="CMU Serif Roman" panose="02000603000000000000" pitchFamily="2" charset="0"/>
-              </a:rPr>
-              <a:t>ection</a:t>
+              <a:t>From the Last Section</a:t>
             </a:r>
             <a:endParaRPr lang="en-US" dirty="0">
               <a:latin typeface="CMU Serif Roman" panose="02000603000000000000" pitchFamily="2" charset="0"/>
@@ -16734,23 +16662,8 @@
                 <a:ea typeface="CMU Serif Roman" panose="02000603000000000000" pitchFamily="2" charset="0"/>
                 <a:cs typeface="CMU Serif Roman" panose="02000603000000000000" pitchFamily="2" charset="0"/>
               </a:rPr>
-              <a:t>We got out of the model:</a:t>
-            </a:r>
-          </a:p>
-          <a:p>
-            <a:pPr marL="0" indent="0">
-              <a:buNone/>
-            </a:pPr>
-            <a:endParaRPr lang="en-GB" dirty="0">
-              <a:latin typeface="CMU Serif Roman" panose="02000603000000000000" pitchFamily="2" charset="0"/>
-              <a:ea typeface="CMU Serif Roman" panose="02000603000000000000" pitchFamily="2" charset="0"/>
-              <a:cs typeface="CMU Serif Roman" panose="02000603000000000000" pitchFamily="2" charset="0"/>
-            </a:endParaRPr>
-          </a:p>
-          <a:p>
-            <a:pPr marL="0" indent="0" algn="ctr">
-              <a:buNone/>
-            </a:pPr>
+              <a:t>We got out of the model: </a:t>
+            </a:r>
             <a:r>
               <a:rPr lang="en-GB" dirty="0">
                 <a:solidFill>
@@ -16831,6 +16744,56 @@
             <a:pPr marL="0" indent="0">
               <a:buNone/>
             </a:pPr>
+            <a:endParaRPr lang="en-GB" dirty="0">
+              <a:latin typeface="CMU Serif Roman" panose="02000603000000000000" pitchFamily="2" charset="0"/>
+              <a:ea typeface="CMU Serif Roman" panose="02000603000000000000" pitchFamily="2" charset="0"/>
+              <a:cs typeface="CMU Serif Roman" panose="02000603000000000000" pitchFamily="2" charset="0"/>
+            </a:endParaRPr>
+          </a:p>
+          <a:p>
+            <a:pPr marL="0" indent="0">
+              <a:buNone/>
+            </a:pPr>
+            <a:endParaRPr lang="en-GB" dirty="0">
+              <a:latin typeface="CMU Serif Roman" panose="02000603000000000000" pitchFamily="2" charset="0"/>
+              <a:ea typeface="CMU Serif Roman" panose="02000603000000000000" pitchFamily="2" charset="0"/>
+              <a:cs typeface="CMU Serif Roman" panose="02000603000000000000" pitchFamily="2" charset="0"/>
+            </a:endParaRPr>
+          </a:p>
+          <a:p>
+            <a:pPr marL="0" indent="0">
+              <a:buNone/>
+            </a:pPr>
+            <a:endParaRPr lang="en-GB" dirty="0">
+              <a:latin typeface="CMU Serif Roman" panose="02000603000000000000" pitchFamily="2" charset="0"/>
+              <a:ea typeface="CMU Serif Roman" panose="02000603000000000000" pitchFamily="2" charset="0"/>
+              <a:cs typeface="CMU Serif Roman" panose="02000603000000000000" pitchFamily="2" charset="0"/>
+            </a:endParaRPr>
+          </a:p>
+          <a:p>
+            <a:pPr marL="0" indent="0">
+              <a:buNone/>
+            </a:pPr>
+            <a:endParaRPr lang="en-GB" dirty="0">
+              <a:latin typeface="CMU Serif Roman" panose="02000603000000000000" pitchFamily="2" charset="0"/>
+              <a:ea typeface="CMU Serif Roman" panose="02000603000000000000" pitchFamily="2" charset="0"/>
+              <a:cs typeface="CMU Serif Roman" panose="02000603000000000000" pitchFamily="2" charset="0"/>
+            </a:endParaRPr>
+          </a:p>
+          <a:p>
+            <a:pPr marL="0" indent="0">
+              <a:buNone/>
+            </a:pPr>
+            <a:endParaRPr lang="en-GB" dirty="0">
+              <a:latin typeface="CMU Serif Roman" panose="02000603000000000000" pitchFamily="2" charset="0"/>
+              <a:ea typeface="CMU Serif Roman" panose="02000603000000000000" pitchFamily="2" charset="0"/>
+              <a:cs typeface="CMU Serif Roman" panose="02000603000000000000" pitchFamily="2" charset="0"/>
+            </a:endParaRPr>
+          </a:p>
+          <a:p>
+            <a:pPr marL="0" indent="0">
+              <a:buNone/>
+            </a:pPr>
             <a:r>
               <a:rPr lang="en-GB" dirty="0">
                 <a:latin typeface="CMU Serif Roman" panose="02000603000000000000" pitchFamily="2" charset="0"/>
@@ -16842,6 +16805,546 @@
           </a:p>
         </p:txBody>
       </p:sp>
+      <mc:AlternateContent xmlns:mc="http://schemas.openxmlformats.org/markup-compatibility/2006">
+        <mc:Choice xmlns:a14="http://schemas.microsoft.com/office/drawing/2010/main" Requires="a14">
+          <p:sp>
+            <p:nvSpPr>
+              <p:cNvPr id="4" name="TextBox 3">
+                <a:extLst>
+                  <a:ext uri="{FF2B5EF4-FFF2-40B4-BE49-F238E27FC236}">
+                    <a16:creationId xmlns:a16="http://schemas.microsoft.com/office/drawing/2014/main" id="{9DD721F7-5D5D-31BA-BFBD-298AAA5F3AEE}"/>
+                  </a:ext>
+                </a:extLst>
+              </p:cNvPr>
+              <p:cNvSpPr txBox="1"/>
+              <p:nvPr/>
+            </p:nvSpPr>
+            <p:spPr>
+              <a:xfrm>
+                <a:off x="4526811" y="3313537"/>
+                <a:ext cx="3138378" cy="1139414"/>
+              </a:xfrm>
+              <a:prstGeom prst="rect">
+                <a:avLst/>
+              </a:prstGeom>
+              <a:noFill/>
+            </p:spPr>
+            <p:txBody>
+              <a:bodyPr wrap="square" lIns="0" tIns="0" rIns="0" bIns="0" rtlCol="0">
+                <a:spAutoFit/>
+              </a:bodyPr>
+              <a:lstStyle/>
+              <a:p>
+                <a14:m>
+                  <m:oMathPara xmlns:m="http://schemas.openxmlformats.org/officeDocument/2006/math">
+                    <m:oMathParaPr>
+                      <m:jc m:val="centerGroup"/>
+                    </m:oMathParaPr>
+                    <m:oMath xmlns:m="http://schemas.openxmlformats.org/officeDocument/2006/math">
+                      <m:d>
+                        <m:dPr>
+                          <m:begChr m:val="["/>
+                          <m:endChr m:val="]"/>
+                          <m:ctrlPr>
+                            <a:rPr lang="en-US" sz="2800" i="1" smtClean="0">
+                              <a:latin typeface="Cambria Math" panose="02040503050406030204" pitchFamily="18" charset="0"/>
+                            </a:rPr>
+                          </m:ctrlPr>
+                        </m:dPr>
+                        <m:e>
+                          <m:m>
+                            <m:mPr>
+                              <m:mcs>
+                                <m:mc>
+                                  <m:mcPr>
+                                    <m:count m:val="3"/>
+                                    <m:mcJc m:val="center"/>
+                                  </m:mcPr>
+                                </m:mc>
+                              </m:mcs>
+                              <m:ctrlPr>
+                                <a:rPr lang="en-US" sz="2800" i="1" smtClean="0">
+                                  <a:latin typeface="Cambria Math" panose="02040503050406030204" pitchFamily="18" charset="0"/>
+                                </a:rPr>
+                              </m:ctrlPr>
+                            </m:mPr>
+                            <m:mr>
+                              <m:e>
+                                <m:r>
+                                  <m:rPr>
+                                    <m:brk m:alnAt="7"/>
+                                  </m:rPr>
+                                  <a:rPr lang="en-GB" sz="2800" b="0" i="1" smtClean="0">
+                                    <a:latin typeface="Cambria Math" panose="02040503050406030204" pitchFamily="18" charset="0"/>
+                                  </a:rPr>
+                                  <m:t>2.7</m:t>
+                                </m:r>
+                              </m:e>
+                              <m:e>
+                                <m:r>
+                                  <a:rPr lang="en-US" sz="2800" i="1" smtClean="0">
+                                    <a:latin typeface="Cambria Math" panose="02040503050406030204" pitchFamily="18" charset="0"/>
+                                  </a:rPr>
+                                  <m:t>⋯</m:t>
+                                </m:r>
+                              </m:e>
+                              <m:e>
+                                <m:r>
+                                  <a:rPr lang="en-GB" sz="2800" b="0" i="1" smtClean="0">
+                                    <a:latin typeface="Cambria Math" panose="02040503050406030204" pitchFamily="18" charset="0"/>
+                                  </a:rPr>
+                                  <m:t>-1.2</m:t>
+                                </m:r>
+                              </m:e>
+                            </m:mr>
+                            <m:mr>
+                              <m:e>
+                                <m:r>
+                                  <a:rPr lang="en-US" sz="2800" i="1" smtClean="0">
+                                    <a:latin typeface="Cambria Math" panose="02040503050406030204" pitchFamily="18" charset="0"/>
+                                  </a:rPr>
+                                  <m:t>⋮</m:t>
+                                </m:r>
+                              </m:e>
+                              <m:e>
+                                <m:r>
+                                  <a:rPr lang="en-US" sz="2800" i="1" smtClean="0">
+                                    <a:latin typeface="Cambria Math" panose="02040503050406030204" pitchFamily="18" charset="0"/>
+                                  </a:rPr>
+                                  <m:t>⋱</m:t>
+                                </m:r>
+                              </m:e>
+                              <m:e>
+                                <m:r>
+                                  <a:rPr lang="en-US" sz="2800" i="1" smtClean="0">
+                                    <a:latin typeface="Cambria Math" panose="02040503050406030204" pitchFamily="18" charset="0"/>
+                                  </a:rPr>
+                                  <m:t>⋮</m:t>
+                                </m:r>
+                              </m:e>
+                            </m:mr>
+                            <m:mr>
+                              <m:e>
+                                <m:r>
+                                  <a:rPr lang="en-GB" sz="2800" b="0" i="1" smtClean="0">
+                                    <a:latin typeface="Cambria Math" panose="02040503050406030204" pitchFamily="18" charset="0"/>
+                                  </a:rPr>
+                                  <m:t>1.1</m:t>
+                                </m:r>
+                              </m:e>
+                              <m:e>
+                                <m:r>
+                                  <a:rPr lang="en-US" sz="2800" i="1" smtClean="0">
+                                    <a:latin typeface="Cambria Math" panose="02040503050406030204" pitchFamily="18" charset="0"/>
+                                  </a:rPr>
+                                  <m:t>⋯</m:t>
+                                </m:r>
+                              </m:e>
+                              <m:e>
+                                <m:r>
+                                  <a:rPr lang="en-GB" sz="2800" b="0" i="1" smtClean="0">
+                                    <a:latin typeface="Cambria Math" panose="02040503050406030204" pitchFamily="18" charset="0"/>
+                                  </a:rPr>
+                                  <m:t>0.8</m:t>
+                                </m:r>
+                              </m:e>
+                            </m:mr>
+                          </m:m>
+                        </m:e>
+                      </m:d>
+                    </m:oMath>
+                  </m:oMathPara>
+                </a14:m>
+                <a:endParaRPr lang="en-US" sz="2800" dirty="0"/>
+              </a:p>
+            </p:txBody>
+          </p:sp>
+        </mc:Choice>
+        <mc:Fallback>
+          <p:sp>
+            <p:nvSpPr>
+              <p:cNvPr id="4" name="TextBox 3">
+                <a:extLst>
+                  <a:ext uri="{FF2B5EF4-FFF2-40B4-BE49-F238E27FC236}">
+                    <a16:creationId xmlns:a16="http://schemas.microsoft.com/office/drawing/2014/main" id="{9DD721F7-5D5D-31BA-BFBD-298AAA5F3AEE}"/>
+                  </a:ext>
+                </a:extLst>
+              </p:cNvPr>
+              <p:cNvSpPr txBox="1">
+                <a:spLocks noRot="1" noChangeAspect="1" noMove="1" noResize="1" noEditPoints="1" noAdjustHandles="1" noChangeArrowheads="1" noChangeShapeType="1" noTextEdit="1"/>
+              </p:cNvSpPr>
+              <p:nvPr/>
+            </p:nvSpPr>
+            <p:spPr>
+              <a:xfrm>
+                <a:off x="4526811" y="3313537"/>
+                <a:ext cx="3138378" cy="1139414"/>
+              </a:xfrm>
+              <a:prstGeom prst="rect">
+                <a:avLst/>
+              </a:prstGeom>
+              <a:blipFill>
+                <a:blip r:embed="rId3"/>
+                <a:stretch>
+                  <a:fillRect t="-1111" b="-10000"/>
+                </a:stretch>
+              </a:blipFill>
+            </p:spPr>
+            <p:txBody>
+              <a:bodyPr/>
+              <a:lstStyle/>
+              <a:p>
+                <a:r>
+                  <a:rPr lang="en-US">
+                    <a:noFill/>
+                  </a:rPr>
+                  <a:t> </a:t>
+                </a:r>
+              </a:p>
+            </p:txBody>
+          </p:sp>
+        </mc:Fallback>
+      </mc:AlternateContent>
+      <p:sp>
+        <p:nvSpPr>
+          <p:cNvPr id="5" name="Left Brace 4">
+            <a:extLst>
+              <a:ext uri="{FF2B5EF4-FFF2-40B4-BE49-F238E27FC236}">
+                <a16:creationId xmlns:a16="http://schemas.microsoft.com/office/drawing/2014/main" id="{F1923C56-A3D7-0983-FE0C-CDCB3776E673}"/>
+              </a:ext>
+            </a:extLst>
+          </p:cNvPr>
+          <p:cNvSpPr/>
+          <p:nvPr/>
+        </p:nvSpPr>
+        <p:spPr>
+          <a:xfrm>
+            <a:off x="4526811" y="3313537"/>
+            <a:ext cx="293842" cy="1139414"/>
+          </a:xfrm>
+          <a:prstGeom prst="leftBrace">
+            <a:avLst/>
+          </a:prstGeom>
+          <a:ln>
+            <a:solidFill>
+              <a:schemeClr val="tx1"/>
+            </a:solidFill>
+          </a:ln>
+        </p:spPr>
+        <p:style>
+          <a:lnRef idx="2">
+            <a:schemeClr val="accent1"/>
+          </a:lnRef>
+          <a:fillRef idx="0">
+            <a:schemeClr val="accent1"/>
+          </a:fillRef>
+          <a:effectRef idx="1">
+            <a:schemeClr val="accent1"/>
+          </a:effectRef>
+          <a:fontRef idx="minor">
+            <a:schemeClr val="tx1"/>
+          </a:fontRef>
+        </p:style>
+        <p:txBody>
+          <a:bodyPr rtlCol="0" anchor="ctr"/>
+          <a:lstStyle/>
+          <a:p>
+            <a:pPr algn="ctr"/>
+            <a:endParaRPr lang="en-US"/>
+          </a:p>
+        </p:txBody>
+      </p:sp>
+      <p:sp>
+        <p:nvSpPr>
+          <p:cNvPr id="6" name="Left Brace 5">
+            <a:extLst>
+              <a:ext uri="{FF2B5EF4-FFF2-40B4-BE49-F238E27FC236}">
+                <a16:creationId xmlns:a16="http://schemas.microsoft.com/office/drawing/2014/main" id="{7AC38CC4-B8B9-0549-3459-8E7068101A7E}"/>
+              </a:ext>
+            </a:extLst>
+          </p:cNvPr>
+          <p:cNvSpPr/>
+          <p:nvPr/>
+        </p:nvSpPr>
+        <p:spPr>
+          <a:xfrm rot="5400000">
+            <a:off x="5932824" y="1975988"/>
+            <a:ext cx="293842" cy="2246319"/>
+          </a:xfrm>
+          <a:prstGeom prst="leftBrace">
+            <a:avLst/>
+          </a:prstGeom>
+          <a:ln>
+            <a:solidFill>
+              <a:schemeClr val="tx1"/>
+            </a:solidFill>
+          </a:ln>
+        </p:spPr>
+        <p:style>
+          <a:lnRef idx="2">
+            <a:schemeClr val="accent1"/>
+          </a:lnRef>
+          <a:fillRef idx="0">
+            <a:schemeClr val="accent1"/>
+          </a:fillRef>
+          <a:effectRef idx="1">
+            <a:schemeClr val="accent1"/>
+          </a:effectRef>
+          <a:fontRef idx="minor">
+            <a:schemeClr val="tx1"/>
+          </a:fontRef>
+        </p:style>
+        <p:txBody>
+          <a:bodyPr rtlCol="0" anchor="ctr"/>
+          <a:lstStyle/>
+          <a:p>
+            <a:pPr algn="ctr"/>
+            <a:endParaRPr lang="en-US"/>
+          </a:p>
+        </p:txBody>
+      </p:sp>
+      <p:sp>
+        <p:nvSpPr>
+          <p:cNvPr id="7" name="TextBox 6">
+            <a:extLst>
+              <a:ext uri="{FF2B5EF4-FFF2-40B4-BE49-F238E27FC236}">
+                <a16:creationId xmlns:a16="http://schemas.microsoft.com/office/drawing/2014/main" id="{302856F2-1956-E41A-2C67-6DE9B5880984}"/>
+              </a:ext>
+            </a:extLst>
+          </p:cNvPr>
+          <p:cNvSpPr txBox="1"/>
+          <p:nvPr/>
+        </p:nvSpPr>
+        <p:spPr>
+          <a:xfrm>
+            <a:off x="2630138" y="3698578"/>
+            <a:ext cx="1896673" cy="369332"/>
+          </a:xfrm>
+          <a:prstGeom prst="rect">
+            <a:avLst/>
+          </a:prstGeom>
+          <a:noFill/>
+        </p:spPr>
+        <p:txBody>
+          <a:bodyPr wrap="none" rtlCol="0">
+            <a:spAutoFit/>
+          </a:bodyPr>
+          <a:lstStyle/>
+          <a:p>
+            <a:r>
+              <a:rPr lang="en-US" dirty="0" err="1">
+                <a:latin typeface="CMU Serif Roman" panose="02000603000000000000" pitchFamily="2" charset="0"/>
+                <a:ea typeface="CMU Serif Roman" panose="02000603000000000000" pitchFamily="2" charset="0"/>
+                <a:cs typeface="CMU Serif Roman" panose="02000603000000000000" pitchFamily="2" charset="0"/>
+              </a:rPr>
+              <a:t>sequence_length</a:t>
+            </a:r>
+            <a:endParaRPr lang="en-US" dirty="0">
+              <a:latin typeface="CMU Serif Roman" panose="02000603000000000000" pitchFamily="2" charset="0"/>
+              <a:ea typeface="CMU Serif Roman" panose="02000603000000000000" pitchFamily="2" charset="0"/>
+              <a:cs typeface="CMU Serif Roman" panose="02000603000000000000" pitchFamily="2" charset="0"/>
+            </a:endParaRPr>
+          </a:p>
+        </p:txBody>
+      </p:sp>
+      <p:sp>
+        <p:nvSpPr>
+          <p:cNvPr id="8" name="TextBox 7">
+            <a:extLst>
+              <a:ext uri="{FF2B5EF4-FFF2-40B4-BE49-F238E27FC236}">
+                <a16:creationId xmlns:a16="http://schemas.microsoft.com/office/drawing/2014/main" id="{1952DE53-07FD-283E-5275-3C7E119F7CCF}"/>
+              </a:ext>
+            </a:extLst>
+          </p:cNvPr>
+          <p:cNvSpPr txBox="1"/>
+          <p:nvPr/>
+        </p:nvSpPr>
+        <p:spPr>
+          <a:xfrm>
+            <a:off x="5160262" y="2582894"/>
+            <a:ext cx="1838965" cy="369332"/>
+          </a:xfrm>
+          <a:prstGeom prst="rect">
+            <a:avLst/>
+          </a:prstGeom>
+          <a:noFill/>
+        </p:spPr>
+        <p:txBody>
+          <a:bodyPr wrap="none" rtlCol="0">
+            <a:spAutoFit/>
+          </a:bodyPr>
+          <a:lstStyle/>
+          <a:p>
+            <a:r>
+              <a:rPr lang="en-US" dirty="0" err="1">
+                <a:latin typeface="CMU Serif Roman" panose="02000603000000000000" pitchFamily="2" charset="0"/>
+                <a:ea typeface="CMU Serif Roman" panose="02000603000000000000" pitchFamily="2" charset="0"/>
+                <a:cs typeface="CMU Serif Roman" panose="02000603000000000000" pitchFamily="2" charset="0"/>
+              </a:rPr>
+              <a:t>embedding_dim</a:t>
+            </a:r>
+            <a:endParaRPr lang="en-US" dirty="0">
+              <a:latin typeface="CMU Serif Roman" panose="02000603000000000000" pitchFamily="2" charset="0"/>
+              <a:ea typeface="CMU Serif Roman" panose="02000603000000000000" pitchFamily="2" charset="0"/>
+              <a:cs typeface="CMU Serif Roman" panose="02000603000000000000" pitchFamily="2" charset="0"/>
+            </a:endParaRPr>
+          </a:p>
+        </p:txBody>
+      </p:sp>
+      <p:sp>
+        <p:nvSpPr>
+          <p:cNvPr id="9" name="Rectangle 8">
+            <a:extLst>
+              <a:ext uri="{FF2B5EF4-FFF2-40B4-BE49-F238E27FC236}">
+                <a16:creationId xmlns:a16="http://schemas.microsoft.com/office/drawing/2014/main" id="{1155574E-BA21-C271-5D42-D6619493BEDE}"/>
+              </a:ext>
+            </a:extLst>
+          </p:cNvPr>
+          <p:cNvSpPr/>
+          <p:nvPr/>
+        </p:nvSpPr>
+        <p:spPr>
+          <a:xfrm>
+            <a:off x="5061284" y="3246069"/>
+            <a:ext cx="2085474" cy="452509"/>
+          </a:xfrm>
+          <a:prstGeom prst="rect">
+            <a:avLst/>
+          </a:prstGeom>
+          <a:solidFill>
+            <a:srgbClr val="1B55EB">
+              <a:alpha val="32000"/>
+            </a:srgbClr>
+          </a:solidFill>
+          <a:ln>
+            <a:noFill/>
+          </a:ln>
+          <a:effectLst>
+            <a:softEdge rad="57129"/>
+          </a:effectLst>
+        </p:spPr>
+        <p:style>
+          <a:lnRef idx="2">
+            <a:schemeClr val="accent1">
+              <a:shade val="15000"/>
+            </a:schemeClr>
+          </a:lnRef>
+          <a:fillRef idx="1">
+            <a:schemeClr val="accent1"/>
+          </a:fillRef>
+          <a:effectRef idx="0">
+            <a:schemeClr val="accent1"/>
+          </a:effectRef>
+          <a:fontRef idx="minor">
+            <a:schemeClr val="lt1"/>
+          </a:fontRef>
+        </p:style>
+        <p:txBody>
+          <a:bodyPr rtlCol="0" anchor="ctr"/>
+          <a:lstStyle/>
+          <a:p>
+            <a:pPr algn="ctr"/>
+            <a:endParaRPr lang="en-US"/>
+          </a:p>
+        </p:txBody>
+      </p:sp>
+      <p:sp>
+        <p:nvSpPr>
+          <p:cNvPr id="10" name="TextBox 9">
+            <a:extLst>
+              <a:ext uri="{FF2B5EF4-FFF2-40B4-BE49-F238E27FC236}">
+                <a16:creationId xmlns:a16="http://schemas.microsoft.com/office/drawing/2014/main" id="{13A22498-D9C3-2FA5-4C1B-D9D0CE806423}"/>
+              </a:ext>
+            </a:extLst>
+          </p:cNvPr>
+          <p:cNvSpPr txBox="1"/>
+          <p:nvPr/>
+        </p:nvSpPr>
+        <p:spPr>
+          <a:xfrm>
+            <a:off x="7905820" y="3246069"/>
+            <a:ext cx="3594647" cy="1200329"/>
+          </a:xfrm>
+          <a:prstGeom prst="rect">
+            <a:avLst/>
+          </a:prstGeom>
+          <a:noFill/>
+        </p:spPr>
+        <p:txBody>
+          <a:bodyPr wrap="square" rtlCol="0">
+            <a:spAutoFit/>
+          </a:bodyPr>
+          <a:lstStyle/>
+          <a:p>
+            <a:r>
+              <a:rPr lang="en-US" dirty="0">
+                <a:solidFill>
+                  <a:srgbClr val="1B55EB"/>
+                </a:solidFill>
+                <a:latin typeface="CMU Serif Roman" panose="02000603000000000000" pitchFamily="2" charset="0"/>
+                <a:ea typeface="CMU Serif Roman" panose="02000603000000000000" pitchFamily="2" charset="0"/>
+                <a:cs typeface="CMU Serif Roman" panose="02000603000000000000" pitchFamily="2" charset="0"/>
+              </a:rPr>
+              <a:t>Context-adjusted embedding vector for a single token</a:t>
+            </a:r>
+          </a:p>
+          <a:p>
+            <a:r>
+              <a:rPr lang="en-US" dirty="0">
+                <a:solidFill>
+                  <a:srgbClr val="1B55EB"/>
+                </a:solidFill>
+                <a:latin typeface="CMU Serif Roman" panose="02000603000000000000" pitchFamily="2" charset="0"/>
+                <a:ea typeface="CMU Serif Roman" panose="02000603000000000000" pitchFamily="2" charset="0"/>
+                <a:cs typeface="CMU Serif Roman" panose="02000603000000000000" pitchFamily="2" charset="0"/>
+              </a:rPr>
+              <a:t>e.g. “the” in “the cat sat on the mat”</a:t>
+            </a:r>
+          </a:p>
+        </p:txBody>
+      </p:sp>
+      <p:cxnSp>
+        <p:nvCxnSpPr>
+          <p:cNvPr id="12" name="Curved Connector 11">
+            <a:extLst>
+              <a:ext uri="{FF2B5EF4-FFF2-40B4-BE49-F238E27FC236}">
+                <a16:creationId xmlns:a16="http://schemas.microsoft.com/office/drawing/2014/main" id="{E002630D-6168-3A23-EF9F-48395C40895B}"/>
+              </a:ext>
+            </a:extLst>
+          </p:cNvPr>
+          <p:cNvCxnSpPr/>
+          <p:nvPr/>
+        </p:nvCxnSpPr>
+        <p:spPr>
+          <a:xfrm rot="10800000">
+            <a:off x="7269018" y="3472323"/>
+            <a:ext cx="636802" cy="373910"/>
+          </a:xfrm>
+          <a:prstGeom prst="curvedConnector3">
+            <a:avLst/>
+          </a:prstGeom>
+          <a:ln>
+            <a:solidFill>
+              <a:srgbClr val="1B55EB"/>
+            </a:solidFill>
+            <a:tailEnd type="triangle"/>
+          </a:ln>
+        </p:spPr>
+        <p:style>
+          <a:lnRef idx="2">
+            <a:schemeClr val="accent1"/>
+          </a:lnRef>
+          <a:fillRef idx="0">
+            <a:schemeClr val="accent1"/>
+          </a:fillRef>
+          <a:effectRef idx="1">
+            <a:schemeClr val="accent1"/>
+          </a:effectRef>
+          <a:fontRef idx="minor">
+            <a:schemeClr val="tx1"/>
+          </a:fontRef>
+        </p:style>
+      </p:cxnSp>
     </p:spTree>
     <p:extLst>
       <p:ext uri="{BB962C8B-B14F-4D97-AF65-F5344CB8AC3E}">
@@ -16852,6 +17355,139 @@
   <p:clrMapOvr>
     <a:masterClrMapping/>
   </p:clrMapOvr>
+  <p:timing>
+    <p:tnLst>
+      <p:par>
+        <p:cTn id="1" dur="indefinite" restart="never" nodeType="tmRoot">
+          <p:childTnLst>
+            <p:seq concurrent="1" nextAc="seek">
+              <p:cTn id="2" dur="indefinite" nodeType="mainSeq">
+                <p:childTnLst>
+                  <p:par>
+                    <p:cTn id="3" fill="hold">
+                      <p:stCondLst>
+                        <p:cond delay="indefinite"/>
+                      </p:stCondLst>
+                      <p:childTnLst>
+                        <p:par>
+                          <p:cTn id="4" fill="hold">
+                            <p:stCondLst>
+                              <p:cond delay="0"/>
+                            </p:stCondLst>
+                            <p:childTnLst>
+                              <p:par>
+                                <p:cTn id="5" presetID="1" presetClass="entr" presetSubtype="0" fill="hold" grpId="0" nodeType="clickEffect">
+                                  <p:stCondLst>
+                                    <p:cond delay="0"/>
+                                  </p:stCondLst>
+                                  <p:childTnLst>
+                                    <p:set>
+                                      <p:cBhvr>
+                                        <p:cTn id="6" dur="1" fill="hold">
+                                          <p:stCondLst>
+                                            <p:cond delay="0"/>
+                                          </p:stCondLst>
+                                        </p:cTn>
+                                        <p:tgtEl>
+                                          <p:spTgt spid="10"/>
+                                        </p:tgtEl>
+                                        <p:attrNameLst>
+                                          <p:attrName>style.visibility</p:attrName>
+                                        </p:attrNameLst>
+                                      </p:cBhvr>
+                                      <p:to>
+                                        <p:strVal val="visible"/>
+                                      </p:to>
+                                    </p:set>
+                                  </p:childTnLst>
+                                </p:cTn>
+                              </p:par>
+                              <p:par>
+                                <p:cTn id="7" presetID="1" presetClass="entr" presetSubtype="0" fill="hold" nodeType="withEffect">
+                                  <p:stCondLst>
+                                    <p:cond delay="0"/>
+                                  </p:stCondLst>
+                                  <p:childTnLst>
+                                    <p:set>
+                                      <p:cBhvr>
+                                        <p:cTn id="8" dur="1" fill="hold">
+                                          <p:stCondLst>
+                                            <p:cond delay="0"/>
+                                          </p:stCondLst>
+                                        </p:cTn>
+                                        <p:tgtEl>
+                                          <p:spTgt spid="12"/>
+                                        </p:tgtEl>
+                                        <p:attrNameLst>
+                                          <p:attrName>style.visibility</p:attrName>
+                                        </p:attrNameLst>
+                                      </p:cBhvr>
+                                      <p:to>
+                                        <p:strVal val="visible"/>
+                                      </p:to>
+                                    </p:set>
+                                  </p:childTnLst>
+                                </p:cTn>
+                              </p:par>
+                              <p:par>
+                                <p:cTn id="9" presetID="1" presetClass="entr" presetSubtype="0" fill="hold" grpId="0" nodeType="withEffect">
+                                  <p:stCondLst>
+                                    <p:cond delay="0"/>
+                                  </p:stCondLst>
+                                  <p:childTnLst>
+                                    <p:set>
+                                      <p:cBhvr>
+                                        <p:cTn id="10" dur="1" fill="hold">
+                                          <p:stCondLst>
+                                            <p:cond delay="0"/>
+                                          </p:stCondLst>
+                                        </p:cTn>
+                                        <p:tgtEl>
+                                          <p:spTgt spid="9"/>
+                                        </p:tgtEl>
+                                        <p:attrNameLst>
+                                          <p:attrName>style.visibility</p:attrName>
+                                        </p:attrNameLst>
+                                      </p:cBhvr>
+                                      <p:to>
+                                        <p:strVal val="visible"/>
+                                      </p:to>
+                                    </p:set>
+                                  </p:childTnLst>
+                                </p:cTn>
+                              </p:par>
+                            </p:childTnLst>
+                          </p:cTn>
+                        </p:par>
+                      </p:childTnLst>
+                    </p:cTn>
+                  </p:par>
+                </p:childTnLst>
+              </p:cTn>
+              <p:prevCondLst>
+                <p:cond evt="onPrev" delay="0">
+                  <p:tgtEl>
+                    <p:sldTgt/>
+                  </p:tgtEl>
+                </p:cond>
+              </p:prevCondLst>
+              <p:nextCondLst>
+                <p:cond evt="onNext" delay="0">
+                  <p:tgtEl>
+                    <p:sldTgt/>
+                  </p:tgtEl>
+                </p:cond>
+              </p:nextCondLst>
+            </p:seq>
+          </p:childTnLst>
+        </p:cTn>
+      </p:par>
+    </p:tnLst>
+    <p:bldLst>
+      <p:bldP spid="9" grpId="0" animBg="1"/>
+      <p:bldP spid="10" grpId="0"/>
+    </p:bldLst>
+  </p:timing>
 </p:sld>
 </file>
 
@@ -17755,8 +18391,8 @@
           </a:fontRef>
         </p:style>
       </p:cxnSp>
-      <mc:AlternateContent xmlns:mc="http://schemas.openxmlformats.org/markup-compatibility/2006">
-        <mc:Choice xmlns:a14="http://schemas.microsoft.com/office/drawing/2010/main" Requires="a14">
+      <mc:AlternateContent xmlns:mc="http://schemas.openxmlformats.org/markup-compatibility/2006" xmlns:a14="http://schemas.microsoft.com/office/drawing/2010/main">
+        <mc:Choice Requires="a14">
           <p:sp>
             <p:nvSpPr>
               <p:cNvPr id="13" name="TextBox 12">
@@ -17819,7 +18455,7 @@
             </p:txBody>
           </p:sp>
         </mc:Choice>
-        <mc:Fallback>
+        <mc:Fallback xmlns="">
           <p:sp>
             <p:nvSpPr>
               <p:cNvPr id="13" name="TextBox 12">
@@ -22802,15 +23438,7 @@
                 <a:ea typeface="CMU Serif Roman" panose="02000603000000000000" pitchFamily="2" charset="0"/>
                 <a:cs typeface="CMU Serif Roman" panose="02000603000000000000" pitchFamily="2" charset="0"/>
               </a:rPr>
-              <a:t>The </a:t>
-            </a:r>
-            <a:r>
-              <a:rPr lang="en-GB">
-                <a:latin typeface="CMU Serif Roman" panose="02000603000000000000" pitchFamily="2" charset="0"/>
-                <a:ea typeface="CMU Serif Roman" panose="02000603000000000000" pitchFamily="2" charset="0"/>
-                <a:cs typeface="CMU Serif Roman" panose="02000603000000000000" pitchFamily="2" charset="0"/>
-              </a:rPr>
-              <a:t>Language Model</a:t>
+              <a:t>The Language Model</a:t>
             </a:r>
             <a:endParaRPr lang="en-US" dirty="0">
               <a:latin typeface="CMU Serif Roman" panose="02000603000000000000" pitchFamily="2" charset="0"/>

</xml_diff>

<commit_message>
chore: add qr code for feedback form
</commit_message>
<xml_diff>
--- a/slides/flsg/6-sampling-flsg.pptx
+++ b/slides/flsg/6-sampling-flsg.pptx
@@ -16805,8 +16805,8 @@
           </a:p>
         </p:txBody>
       </p:sp>
-      <mc:AlternateContent xmlns:mc="http://schemas.openxmlformats.org/markup-compatibility/2006">
-        <mc:Choice xmlns:a14="http://schemas.microsoft.com/office/drawing/2010/main" Requires="a14">
+      <mc:AlternateContent xmlns:mc="http://schemas.openxmlformats.org/markup-compatibility/2006" xmlns:a14="http://schemas.microsoft.com/office/drawing/2010/main">
+        <mc:Choice Requires="a14">
           <p:sp>
             <p:nvSpPr>
               <p:cNvPr id="4" name="TextBox 3">
@@ -16835,6 +16835,7 @@
               </a:bodyPr>
               <a:lstStyle/>
               <a:p>
+                <a:pPr/>
                 <a14:m>
                   <m:oMathPara xmlns:m="http://schemas.openxmlformats.org/officeDocument/2006/math">
                     <m:oMathParaPr>
@@ -16877,7 +16878,13 @@
                                   <a:rPr lang="en-GB" sz="2800" b="0" i="1" smtClean="0">
                                     <a:latin typeface="Cambria Math" panose="02040503050406030204" pitchFamily="18" charset="0"/>
                                   </a:rPr>
-                                  <m:t>2.7</m:t>
+                                  <m:t>2</m:t>
+                                </m:r>
+                                <m:r>
+                                  <a:rPr lang="en-GB" sz="2800" b="0" i="1" smtClean="0">
+                                    <a:latin typeface="Cambria Math" panose="02040503050406030204" pitchFamily="18" charset="0"/>
+                                  </a:rPr>
+                                  <m:t>.7</m:t>
                                 </m:r>
                               </m:e>
                               <m:e>
@@ -16893,7 +16900,7 @@
                                   <a:rPr lang="en-GB" sz="2800" b="0" i="1" smtClean="0">
                                     <a:latin typeface="Cambria Math" panose="02040503050406030204" pitchFamily="18" charset="0"/>
                                   </a:rPr>
-                                  <m:t>-1.2</m:t>
+                                  <m:t>−1.2</m:t>
                                 </m:r>
                               </m:e>
                             </m:mr>
@@ -16960,7 +16967,7 @@
             </p:txBody>
           </p:sp>
         </mc:Choice>
-        <mc:Fallback>
+        <mc:Fallback xmlns="">
           <p:sp>
             <p:nvSpPr>
               <p:cNvPr id="4" name="TextBox 3">

</xml_diff>